<commit_message>
Revise G3 briefing to separate confirmed settings from pending decisions
</commit_message>
<xml_diff>
--- a/output/slides/G3-engine-briefing-zh-HK.pptx
+++ b/output/slides/G3-engine-briefing-zh-HK.pptx
@@ -647,7 +647,7 @@
           <a:lstStyle/>
           <a:p>
             <a:r>
-              <a:t>策略時間以紐約為準：前日早市 09:30–12:30、午市 12:30–16:00；當日觀察 09:30–10:00 及 12:30–13:00；初始價 10:00 及 13:00；清倉 12:30 及 16:00。端點和半日市仍待決定。B 是門檻事件數，R 是方向轉換數，h 是持倉反向確認數，三者不可混淆。</a:t>
+              <a:t>核對依據：docs/G3-checklist-01-source-audit-zh-HK.md。逐字稿01與02位於 imports/AL-briefing-01/。01：01 00:09:31、00:10:51–00:12:21；02 00:00:33、00:07:04–00:08:17。02：01 00:00:56–00:01:25；02 00:02:42–00:03:20、00:05:01–00:05:10；午市13:00補自圖5。03：01 00:11:22–00:11:49；02 00:03:13–00:03:20、00:05:10–00:05:30；圖2。04：01 00:04:13–00:05:56；02 00:06:16–00:07:19。05：01 00:01:32–00:02:48；圖1。06：01 00:01:25–00:01:32、00:03:55。07：已檢視來源未有完整政策，不是宣稱用戶從未定義。08：01 00:09:04–00:10:57、00:13:41–00:16:03、00:18:37；圖3。不以舊稿建議或 compare.py 假設代替策略批准。briefing digest 01c 的 chatgpt.com/local 連結尚未能讀取。</a:t>
             </a:r>
           </a:p>
         </p:txBody>
@@ -673,6 +673,76 @@
 </file>
 
 <file path=ppt/notesSlides/notesSlide4.xml><?xml version="1.0" encoding="utf-8"?>
+<p:notes xmlns:a="http://schemas.openxmlformats.org/drawingml/2006/main" xmlns:p="http://schemas.openxmlformats.org/presentationml/2006/main" xmlns:r="http://schemas.openxmlformats.org/officeDocument/2006/relationships">
+  <p:cSld>
+    <p:spTree>
+      <p:nvGrpSpPr>
+        <p:cNvPr id="1" name=""/>
+        <p:cNvGrpSpPr/>
+        <p:nvPr/>
+      </p:nvGrpSpPr>
+      <p:grpSpPr>
+        <a:xfrm>
+          <a:off x="0" y="0"/>
+          <a:ext cx="0" cy="0"/>
+          <a:chOff x="0" y="0"/>
+          <a:chExt cx="0" cy="0"/>
+        </a:xfrm>
+      </p:grpSpPr>
+      <p:sp>
+        <p:nvSpPr>
+          <p:cNvPr id="2" name="Slide Image Placeholder 1"/>
+          <p:cNvSpPr>
+            <a:spLocks noGrp="1"/>
+          </p:cNvSpPr>
+          <p:nvPr>
+            <p:ph type="sldImg" idx="2"/>
+          </p:nvPr>
+        </p:nvSpPr>
+        <p:spPr/>
+      </p:sp>
+      <p:sp>
+        <p:nvSpPr>
+          <p:cNvPr id="3" name="Notes Placeholder 2"/>
+          <p:cNvSpPr>
+            <a:spLocks noGrp="1"/>
+          </p:cNvSpPr>
+          <p:nvPr>
+            <p:ph type="body" idx="3" sz="quarter"/>
+          </p:nvPr>
+        </p:nvSpPr>
+        <p:spPr/>
+        <p:txBody>
+          <a:bodyPr/>
+          <a:lstStyle/>
+          <a:p>
+            <a:r>
+              <a:t>策略時間以紐約為準：前日早市 09:30–12:30、午市 12:30–16:00；當日觀察 09:30–10:00 及 12:30–13:00；初始價 10:00 及 13:00；清倉 12:30 及 16:00。端點和半日市仍待決定。B 是門檻事件數，R 是方向轉換數，h 是持倉反向確認數，三者不可混淆。</a:t>
+            </a:r>
+          </a:p>
+        </p:txBody>
+      </p:sp>
+      <p:sp>
+        <p:nvSpPr>
+          <p:cNvPr id="4" name="Slide Number Placeholder 3"/>
+          <p:cNvSpPr>
+            <a:spLocks noGrp="1"/>
+          </p:cNvSpPr>
+          <p:nvPr>
+            <p:ph type="sldNum" idx="5" sz="quarter"/>
+          </p:nvPr>
+        </p:nvSpPr>
+        <p:spPr/>
+      </p:sp>
+    </p:spTree>
+  </p:cSld>
+  <p:clrMapOvr>
+    <a:masterClrMapping/>
+  </p:clrMapOvr>
+</p:notes>
+</file>
+
+<file path=ppt/notesSlides/notesSlide5.xml><?xml version="1.0" encoding="utf-8"?>
 <p:notes xmlns:a="http://schemas.openxmlformats.org/drawingml/2006/main" xmlns:p="http://schemas.openxmlformats.org/presentationml/2006/main" xmlns:r="http://schemas.openxmlformats.org/officeDocument/2006/relationships">
   <p:cSld>
     <p:spTree>
@@ -3926,7 +3996,7 @@
               </a:defRPr>
             </a:pPr>
             <a:r>
-              <a:t>依據：v3 規格、G3 修訂計劃及三份代理審閱｜審閱稿・2026 年 10 月 29 日｜引擎尚未建成</a:t>
+              <a:t>依據：v3、G3 計劃及原始來源核對｜修訂版・2026 年 10 月 29 日｜引擎尚未建成</a:t>
             </a:r>
           </a:p>
         </p:txBody>
@@ -5994,7 +6064,7 @@
               </a:defRPr>
             </a:pPr>
             <a:r>
-              <a:t>首版理想化；限制及成本須列明</a:t>
+              <a:t>建議首版理想化；限制及成本須列明</a:t>
             </a:r>
           </a:p>
         </p:txBody>
@@ -6460,7 +6530,7 @@
               </a:defRPr>
             </a:pPr>
             <a:r>
-              <a:t>目前位置：規格及審閱文件已齊；G1／G2 的待定規則與歷史資料仍須落實。</a:t>
+              <a:t>目前已有策略框架；只補齊未決細節及資料。01c 對話未取得，不代表當中沒有答案。</a:t>
             </a:r>
           </a:p>
         </p:txBody>
@@ -6543,7 +6613,7 @@
               </a:defRPr>
             </a:pPr>
             <a:r>
-              <a:t>依據：v3 規格、G3 修訂計劃及三份代理審閱｜審閱稿・2026 年 10 月 29 日｜引擎尚未建成</a:t>
+              <a:t>依據：v3、G3 計劃及原始來源核對｜修訂版・2026 年 10 月 29 日｜引擎尚未建成</a:t>
             </a:r>
           </a:p>
         </p:txBody>
@@ -6747,7 +6817,7 @@
               </a:defRPr>
             </a:pPr>
             <a:r>
-              <a:t>決策清單逐項拍板</a:t>
+              <a:t>沿用已確認策略</a:t>
             </a:r>
           </a:p>
           <a:p>
@@ -6763,7 +6833,7 @@
               </a:defRPr>
             </a:pPr>
             <a:r>
-              <a:t>獨立手算標準答案</a:t>
+              <a:t>補齊細節及手算答案</a:t>
             </a:r>
           </a:p>
         </p:txBody>
@@ -8406,7 +8476,7 @@
               </a:defRPr>
             </a:pPr>
             <a:r>
-              <a:t>開工前清單（一）：資料及訊號定義</a:t>
+              <a:t>清單（一）：已有設定與尚欠細節</a:t>
             </a:r>
           </a:p>
         </p:txBody>
@@ -8445,7 +8515,7 @@
               </a:defRPr>
             </a:pPr>
             <a:r>
-              <a:t>逐項記錄選項、決定、負責人及日期；已有規格不需要重新推翻。</a:t>
+              <a:t>沿用有證據的設定，只處理餘下問題；「未找到」只適用於已檢視的來源。</a:t>
             </a:r>
           </a:p>
         </p:txBody>
@@ -8528,7 +8598,7 @@
               </a:defRPr>
             </a:pPr>
             <a:r>
-              <a:t>依據：v3 規格、G3 修訂計劃及三份代理審閱｜審閱稿・2026 年 10 月 29 日｜引擎尚未建成</a:t>
+              <a:t>依據：v3、G3 計劃及原始來源核對｜修訂版・2026 年 10 月 29 日｜引擎尚未建成</a:t>
             </a:r>
           </a:p>
         </p:txBody>
@@ -8580,8 +8650,257 @@
         </p:nvSpPr>
         <p:spPr>
           <a:xfrm>
-            <a:off x="457200" y="1856231"/>
-            <a:ext cx="11247120" cy="466344"/>
+            <a:off x="457200" y="1819656"/>
+            <a:ext cx="1737360" cy="274320"/>
+          </a:xfrm>
+          <a:prstGeom prst="rect">
+            <a:avLst/>
+          </a:prstGeom>
+          <a:solidFill>
+            <a:srgbClr val="173443"/>
+          </a:solidFill>
+          <a:ln>
+            <a:noFill/>
+          </a:ln>
+          <a:effectLst/>
+        </p:spPr>
+        <p:style>
+          <a:lnRef idx="1">
+            <a:schemeClr val="accent1"/>
+          </a:lnRef>
+          <a:fillRef idx="3">
+            <a:schemeClr val="accent1"/>
+          </a:fillRef>
+          <a:effectRef idx="2">
+            <a:schemeClr val="accent1"/>
+          </a:effectRef>
+          <a:fontRef idx="minor">
+            <a:schemeClr val="lt1"/>
+          </a:fontRef>
+        </p:style>
+        <p:txBody>
+          <a:bodyPr rtlCol="0" anchor="ctr"/>
+          <a:lstStyle/>
+          <a:p>
+            <a:pPr algn="ctr"/>
+          </a:p>
+        </p:txBody>
+      </p:sp>
+      <p:sp>
+        <p:nvSpPr>
+          <p:cNvPr id="9" name="TextBox 8"/>
+          <p:cNvSpPr txBox="1"/>
+          <p:nvPr/>
+        </p:nvSpPr>
+        <p:spPr>
+          <a:xfrm>
+            <a:off x="530352" y="1847088"/>
+            <a:ext cx="1591056" cy="228600"/>
+          </a:xfrm>
+          <a:prstGeom prst="rect">
+            <a:avLst/>
+          </a:prstGeom>
+          <a:noFill/>
+        </p:spPr>
+        <p:txBody>
+          <a:bodyPr wrap="square" lIns="9144" rIns="9144" tIns="0" bIns="0">
+            <a:spAutoFit/>
+          </a:bodyPr>
+          <a:lstStyle/>
+          <a:p>
+            <a:pPr>
+              <a:spcAft>
+                <a:spcPts val="400"/>
+              </a:spcAft>
+              <a:defRPr sz="1100" b="1">
+                <a:solidFill>
+                  <a:srgbClr val="FFFFFF"/>
+                </a:solidFill>
+                <a:latin typeface="Noto Sans CJK TC"/>
+              </a:defRPr>
+            </a:pPr>
+            <a:r>
+              <a:t>項目</a:t>
+            </a:r>
+          </a:p>
+        </p:txBody>
+      </p:sp>
+      <p:sp>
+        <p:nvSpPr>
+          <p:cNvPr id="10" name="Rectangle 9"/>
+          <p:cNvSpPr/>
+          <p:nvPr/>
+        </p:nvSpPr>
+        <p:spPr>
+          <a:xfrm>
+            <a:off x="2194560" y="1819656"/>
+            <a:ext cx="3657600" cy="274320"/>
+          </a:xfrm>
+          <a:prstGeom prst="rect">
+            <a:avLst/>
+          </a:prstGeom>
+          <a:solidFill>
+            <a:srgbClr val="173443"/>
+          </a:solidFill>
+          <a:ln>
+            <a:noFill/>
+          </a:ln>
+          <a:effectLst/>
+        </p:spPr>
+        <p:style>
+          <a:lnRef idx="1">
+            <a:schemeClr val="accent1"/>
+          </a:lnRef>
+          <a:fillRef idx="3">
+            <a:schemeClr val="accent1"/>
+          </a:fillRef>
+          <a:effectRef idx="2">
+            <a:schemeClr val="accent1"/>
+          </a:effectRef>
+          <a:fontRef idx="minor">
+            <a:schemeClr val="lt1"/>
+          </a:fontRef>
+        </p:style>
+        <p:txBody>
+          <a:bodyPr rtlCol="0" anchor="ctr"/>
+          <a:lstStyle/>
+          <a:p>
+            <a:pPr algn="ctr"/>
+          </a:p>
+        </p:txBody>
+      </p:sp>
+      <p:sp>
+        <p:nvSpPr>
+          <p:cNvPr id="11" name="TextBox 10"/>
+          <p:cNvSpPr txBox="1"/>
+          <p:nvPr/>
+        </p:nvSpPr>
+        <p:spPr>
+          <a:xfrm>
+            <a:off x="2267712" y="1847088"/>
+            <a:ext cx="3511296" cy="228600"/>
+          </a:xfrm>
+          <a:prstGeom prst="rect">
+            <a:avLst/>
+          </a:prstGeom>
+          <a:noFill/>
+        </p:spPr>
+        <p:txBody>
+          <a:bodyPr wrap="square" lIns="9144" rIns="9144" tIns="0" bIns="0">
+            <a:spAutoFit/>
+          </a:bodyPr>
+          <a:lstStyle/>
+          <a:p>
+            <a:pPr>
+              <a:spcAft>
+                <a:spcPts val="400"/>
+              </a:spcAft>
+              <a:defRPr sz="1100" b="1">
+                <a:solidFill>
+                  <a:srgbClr val="FFFFFF"/>
+                </a:solidFill>
+                <a:latin typeface="Noto Sans CJK TC"/>
+              </a:defRPr>
+            </a:pPr>
+            <a:r>
+              <a:t>已有設定｜不用重新決定</a:t>
+            </a:r>
+          </a:p>
+        </p:txBody>
+      </p:sp>
+      <p:sp>
+        <p:nvSpPr>
+          <p:cNvPr id="12" name="Rectangle 11"/>
+          <p:cNvSpPr/>
+          <p:nvPr/>
+        </p:nvSpPr>
+        <p:spPr>
+          <a:xfrm>
+            <a:off x="5852160" y="1819656"/>
+            <a:ext cx="5852160" cy="274320"/>
+          </a:xfrm>
+          <a:prstGeom prst="rect">
+            <a:avLst/>
+          </a:prstGeom>
+          <a:solidFill>
+            <a:srgbClr val="173443"/>
+          </a:solidFill>
+          <a:ln>
+            <a:noFill/>
+          </a:ln>
+          <a:effectLst/>
+        </p:spPr>
+        <p:style>
+          <a:lnRef idx="1">
+            <a:schemeClr val="accent1"/>
+          </a:lnRef>
+          <a:fillRef idx="3">
+            <a:schemeClr val="accent1"/>
+          </a:fillRef>
+          <a:effectRef idx="2">
+            <a:schemeClr val="accent1"/>
+          </a:effectRef>
+          <a:fontRef idx="minor">
+            <a:schemeClr val="lt1"/>
+          </a:fontRef>
+        </p:style>
+        <p:txBody>
+          <a:bodyPr rtlCol="0" anchor="ctr"/>
+          <a:lstStyle/>
+          <a:p>
+            <a:pPr algn="ctr"/>
+          </a:p>
+        </p:txBody>
+      </p:sp>
+      <p:sp>
+        <p:nvSpPr>
+          <p:cNvPr id="13" name="TextBox 12"/>
+          <p:cNvSpPr txBox="1"/>
+          <p:nvPr/>
+        </p:nvSpPr>
+        <p:spPr>
+          <a:xfrm>
+            <a:off x="5925312" y="1847088"/>
+            <a:ext cx="5705856" cy="228600"/>
+          </a:xfrm>
+          <a:prstGeom prst="rect">
+            <a:avLst/>
+          </a:prstGeom>
+          <a:noFill/>
+        </p:spPr>
+        <p:txBody>
+          <a:bodyPr wrap="square" lIns="9144" rIns="9144" tIns="0" bIns="0">
+            <a:spAutoFit/>
+          </a:bodyPr>
+          <a:lstStyle/>
+          <a:p>
+            <a:pPr>
+              <a:spcAft>
+                <a:spcPts val="400"/>
+              </a:spcAft>
+              <a:defRPr sz="1100" b="1">
+                <a:solidFill>
+                  <a:srgbClr val="FFFFFF"/>
+                </a:solidFill>
+                <a:latin typeface="Noto Sans CJK TC"/>
+              </a:defRPr>
+            </a:pPr>
+            <a:r>
+              <a:t>待補細節／交付選擇</a:t>
+            </a:r>
+          </a:p>
+        </p:txBody>
+      </p:sp>
+      <p:sp>
+        <p:nvSpPr>
+          <p:cNvPr id="14" name="Rectangle 13"/>
+          <p:cNvSpPr/>
+          <p:nvPr/>
+        </p:nvSpPr>
+        <p:spPr>
+          <a:xfrm>
+            <a:off x="457200" y="2121408"/>
+            <a:ext cx="11247120" cy="461772"/>
           </a:xfrm>
           <a:prstGeom prst="rect">
             <a:avLst/>
@@ -8618,60 +8937,14 @@
       </p:sp>
       <p:sp>
         <p:nvSpPr>
-          <p:cNvPr id="9" name="Rectangle 8"/>
-          <p:cNvSpPr/>
-          <p:nvPr/>
-        </p:nvSpPr>
-        <p:spPr>
-          <a:xfrm>
-            <a:off x="585216" y="1975103"/>
-            <a:ext cx="155448" cy="155448"/>
-          </a:xfrm>
-          <a:prstGeom prst="rect">
-            <a:avLst/>
-          </a:prstGeom>
-          <a:solidFill>
-            <a:srgbClr val="FFFFFF"/>
-          </a:solidFill>
-          <a:ln>
-            <a:solidFill>
-              <a:srgbClr val="087C83"/>
-            </a:solidFill>
-          </a:ln>
-          <a:effectLst/>
-        </p:spPr>
-        <p:style>
-          <a:lnRef idx="1">
-            <a:schemeClr val="accent1"/>
-          </a:lnRef>
-          <a:fillRef idx="3">
-            <a:schemeClr val="accent1"/>
-          </a:fillRef>
-          <a:effectRef idx="2">
-            <a:schemeClr val="accent1"/>
-          </a:effectRef>
-          <a:fontRef idx="minor">
-            <a:schemeClr val="lt1"/>
-          </a:fontRef>
-        </p:style>
-        <p:txBody>
-          <a:bodyPr rtlCol="0" anchor="ctr"/>
-          <a:lstStyle/>
-          <a:p>
-            <a:pPr algn="ctr"/>
-          </a:p>
-        </p:txBody>
-      </p:sp>
-      <p:sp>
-        <p:nvSpPr>
-          <p:cNvPr id="10" name="TextBox 9"/>
+          <p:cNvPr id="15" name="TextBox 14"/>
           <p:cNvSpPr txBox="1"/>
           <p:nvPr/>
         </p:nvSpPr>
         <p:spPr>
           <a:xfrm>
-            <a:off x="850392" y="1947672"/>
-            <a:ext cx="384048" cy="274320"/>
+            <a:off x="539496" y="2221991"/>
+            <a:ext cx="1609344" cy="274320"/>
           </a:xfrm>
           <a:prstGeom prst="rect">
             <a:avLst/>
@@ -8690,27 +8963,27 @@
               </a:spcAft>
               <a:defRPr sz="1200" b="1">
                 <a:solidFill>
-                  <a:srgbClr val="087C83"/>
-                </a:solidFill>
-                <a:latin typeface="Noto Sans CJK TC"/>
-              </a:defRPr>
-            </a:pPr>
-            <a:r>
-              <a:t>01</a:t>
-            </a:r>
-          </a:p>
-        </p:txBody>
-      </p:sp>
-      <p:sp>
-        <p:nvSpPr>
-          <p:cNvPr id="11" name="TextBox 10"/>
+                  <a:srgbClr val="173443"/>
+                </a:solidFill>
+                <a:latin typeface="Noto Sans CJK TC"/>
+              </a:defRPr>
+            </a:pPr>
+            <a:r>
+              <a:t>01 首版範圍</a:t>
+            </a:r>
+          </a:p>
+        </p:txBody>
+      </p:sp>
+      <p:sp>
+        <p:nvSpPr>
+          <p:cNvPr id="16" name="TextBox 15"/>
           <p:cNvSpPr txBox="1"/>
           <p:nvPr/>
         </p:nvSpPr>
         <p:spPr>
           <a:xfrm>
-            <a:off x="1298448" y="1911095"/>
-            <a:ext cx="3108960" cy="356616"/>
+            <a:off x="2267712" y="2144268"/>
+            <a:ext cx="3493008" cy="429768"/>
           </a:xfrm>
           <a:prstGeom prst="rect">
             <a:avLst/>
@@ -8727,29 +9000,45 @@
               <a:spcAft>
                 <a:spcPts val="400"/>
               </a:spcAft>
-              <a:defRPr sz="1500" b="1">
-                <a:solidFill>
-                  <a:srgbClr val="173443"/>
-                </a:solidFill>
-                <a:latin typeface="Noto Sans CJK TC"/>
-              </a:defRPr>
-            </a:pPr>
-            <a:r>
-              <a:t>批准首版範圍</a:t>
-            </a:r>
-          </a:p>
-        </p:txBody>
-      </p:sp>
-      <p:sp>
-        <p:nvSpPr>
-          <p:cNvPr id="12" name="TextBox 11"/>
+              <a:defRPr sz="1150" b="0">
+                <a:solidFill>
+                  <a:srgbClr val="087C83"/>
+                </a:solidFill>
+                <a:latin typeface="Noto Sans CJK TC"/>
+              </a:defRPr>
+            </a:pPr>
+            <a:r>
+              <a:t>早／午市、h＝1、開關可移除；</a:t>
+            </a:r>
+          </a:p>
+          <a:p>
+            <a:pPr>
+              <a:spcAft>
+                <a:spcPts val="400"/>
+              </a:spcAft>
+              <a:defRPr sz="1150" b="0">
+                <a:solidFill>
+                  <a:srgbClr val="087C83"/>
+                </a:solidFill>
+                <a:latin typeface="Noto Sans CJK TC"/>
+              </a:defRPr>
+            </a:pPr>
+            <a:r>
+              <a:t>美元門檻及百分比選項已有要求。</a:t>
+            </a:r>
+          </a:p>
+        </p:txBody>
+      </p:sp>
+      <p:sp>
+        <p:nvSpPr>
+          <p:cNvPr id="17" name="TextBox 16"/>
           <p:cNvSpPr txBox="1"/>
           <p:nvPr/>
         </p:nvSpPr>
         <p:spPr>
           <a:xfrm>
-            <a:off x="4407408" y="1938527"/>
-            <a:ext cx="7114032" cy="338328"/>
+            <a:off x="5925312" y="2144268"/>
+            <a:ext cx="5669280" cy="429768"/>
           </a:xfrm>
           <a:prstGeom prst="rect">
             <a:avLst/>
@@ -8766,29 +9055,45 @@
               <a:spcAft>
                 <a:spcPts val="400"/>
               </a:spcAft>
-              <a:defRPr sz="1200" b="0">
-                <a:solidFill>
-                  <a:srgbClr val="526874"/>
-                </a:solidFill>
-                <a:latin typeface="Noto Sans CJK TC"/>
-              </a:defRPr>
-            </a:pPr>
-            <a:r>
-              <a:t>確認 h＝1、早／午市、可開關交易閘；先選一種已定義的 Renko 模式。</a:t>
-            </a:r>
-          </a:p>
-        </p:txBody>
-      </p:sp>
-      <p:sp>
-        <p:nvSpPr>
-          <p:cNvPr id="13" name="Rectangle 12"/>
+              <a:defRPr sz="1150" b="0">
+                <a:solidFill>
+                  <a:srgbClr val="173443"/>
+                </a:solidFill>
+                <a:latin typeface="Noto Sans CJK TC"/>
+              </a:defRPr>
+            </a:pPr>
+            <a:r>
+              <a:t>只批准首版交付分期；「先做一種模式」是工程建議，</a:t>
+            </a:r>
+          </a:p>
+          <a:p>
+            <a:pPr>
+              <a:spcAft>
+                <a:spcPts val="400"/>
+              </a:spcAft>
+              <a:defRPr sz="1150" b="0">
+                <a:solidFill>
+                  <a:srgbClr val="173443"/>
+                </a:solidFill>
+                <a:latin typeface="Noto Sans CJK TC"/>
+              </a:defRPr>
+            </a:pPr>
+            <a:r>
+              <a:t>不是重問策略方向。h＝2／3 仍須完整規則。</a:t>
+            </a:r>
+          </a:p>
+        </p:txBody>
+      </p:sp>
+      <p:sp>
+        <p:nvSpPr>
+          <p:cNvPr id="18" name="Rectangle 17"/>
           <p:cNvSpPr/>
           <p:nvPr/>
         </p:nvSpPr>
         <p:spPr>
           <a:xfrm>
-            <a:off x="457200" y="2377439"/>
-            <a:ext cx="11247120" cy="466344"/>
+            <a:off x="457200" y="2610612"/>
+            <a:ext cx="11247120" cy="461772"/>
           </a:xfrm>
           <a:prstGeom prst="rect">
             <a:avLst/>
@@ -8825,60 +9130,14 @@
       </p:sp>
       <p:sp>
         <p:nvSpPr>
-          <p:cNvPr id="14" name="Rectangle 13"/>
-          <p:cNvSpPr/>
-          <p:nvPr/>
-        </p:nvSpPr>
-        <p:spPr>
-          <a:xfrm>
-            <a:off x="585216" y="2496311"/>
-            <a:ext cx="155448" cy="155448"/>
-          </a:xfrm>
-          <a:prstGeom prst="rect">
-            <a:avLst/>
-          </a:prstGeom>
-          <a:solidFill>
-            <a:srgbClr val="FFFFFF"/>
-          </a:solidFill>
-          <a:ln>
-            <a:solidFill>
-              <a:srgbClr val="087C83"/>
-            </a:solidFill>
-          </a:ln>
-          <a:effectLst/>
-        </p:spPr>
-        <p:style>
-          <a:lnRef idx="1">
-            <a:schemeClr val="accent1"/>
-          </a:lnRef>
-          <a:fillRef idx="3">
-            <a:schemeClr val="accent1"/>
-          </a:fillRef>
-          <a:effectRef idx="2">
-            <a:schemeClr val="accent1"/>
-          </a:effectRef>
-          <a:fontRef idx="minor">
-            <a:schemeClr val="lt1"/>
-          </a:fontRef>
-        </p:style>
-        <p:txBody>
-          <a:bodyPr rtlCol="0" anchor="ctr"/>
-          <a:lstStyle/>
-          <a:p>
-            <a:pPr algn="ctr"/>
-          </a:p>
-        </p:txBody>
-      </p:sp>
-      <p:sp>
-        <p:nvSpPr>
-          <p:cNvPr id="15" name="TextBox 14"/>
+          <p:cNvPr id="19" name="TextBox 18"/>
           <p:cNvSpPr txBox="1"/>
           <p:nvPr/>
         </p:nvSpPr>
         <p:spPr>
           <a:xfrm>
-            <a:off x="850392" y="2468879"/>
-            <a:ext cx="384048" cy="274320"/>
+            <a:off x="539496" y="2711196"/>
+            <a:ext cx="1609344" cy="274320"/>
           </a:xfrm>
           <a:prstGeom prst="rect">
             <a:avLst/>
@@ -8897,27 +9156,27 @@
               </a:spcAft>
               <a:defRPr sz="1200" b="1">
                 <a:solidFill>
-                  <a:srgbClr val="087C83"/>
-                </a:solidFill>
-                <a:latin typeface="Noto Sans CJK TC"/>
-              </a:defRPr>
-            </a:pPr>
-            <a:r>
-              <a:t>02</a:t>
-            </a:r>
-          </a:p>
-        </p:txBody>
-      </p:sp>
-      <p:sp>
-        <p:nvSpPr>
-          <p:cNvPr id="16" name="TextBox 15"/>
+                  <a:srgbClr val="173443"/>
+                </a:solidFill>
+                <a:latin typeface="Noto Sans CJK TC"/>
+              </a:defRPr>
+            </a:pPr>
+            <a:r>
+              <a:t>02 用價及時間</a:t>
+            </a:r>
+          </a:p>
+        </p:txBody>
+      </p:sp>
+      <p:sp>
+        <p:nvSpPr>
+          <p:cNvPr id="20" name="TextBox 19"/>
           <p:cNvSpPr txBox="1"/>
           <p:nvPr/>
         </p:nvSpPr>
         <p:spPr>
           <a:xfrm>
-            <a:off x="1298448" y="2432303"/>
-            <a:ext cx="3108960" cy="356616"/>
+            <a:off x="2267712" y="2633472"/>
+            <a:ext cx="3493008" cy="429768"/>
           </a:xfrm>
           <a:prstGeom prst="rect">
             <a:avLst/>
@@ -8934,29 +9193,45 @@
               <a:spcAft>
                 <a:spcPts val="400"/>
               </a:spcAft>
-              <a:defRPr sz="1500" b="1">
-                <a:solidFill>
-                  <a:srgbClr val="173443"/>
-                </a:solidFill>
-                <a:latin typeface="Noto Sans CJK TC"/>
-              </a:defRPr>
-            </a:pPr>
-            <a:r>
-              <a:t>定義每分鐘用價及時間</a:t>
-            </a:r>
-          </a:p>
-        </p:txBody>
-      </p:sp>
-      <p:sp>
-        <p:nvSpPr>
-          <p:cNvPr id="17" name="TextBox 16"/>
+              <a:defRPr sz="1150" b="0">
+                <a:solidFill>
+                  <a:srgbClr val="087C83"/>
+                </a:solidFill>
+                <a:latin typeface="Noto Sans CJK TC"/>
+              </a:defRPr>
+            </a:pPr>
+            <a:r>
+              <a:t>每分鐘一次；上午 10:00 記初始價；</a:t>
+            </a:r>
+          </a:p>
+          <a:p>
+            <a:pPr>
+              <a:spcAft>
+                <a:spcPts val="400"/>
+              </a:spcAft>
+              <a:defRPr sz="1150" b="0">
+                <a:solidFill>
+                  <a:srgbClr val="087C83"/>
+                </a:solidFill>
+                <a:latin typeface="Noto Sans CJK TC"/>
+              </a:defRPr>
+            </a:pPr>
+            <a:r>
+              <a:t>首事件以該初始價作基準。</a:t>
+            </a:r>
+          </a:p>
+        </p:txBody>
+      </p:sp>
+      <p:sp>
+        <p:nvSpPr>
+          <p:cNvPr id="21" name="TextBox 20"/>
           <p:cNvSpPr txBox="1"/>
           <p:nvPr/>
         </p:nvSpPr>
         <p:spPr>
           <a:xfrm>
-            <a:off x="4407408" y="2459735"/>
-            <a:ext cx="7114032" cy="338328"/>
+            <a:off x="5925312" y="2633472"/>
+            <a:ext cx="5669280" cy="429768"/>
           </a:xfrm>
           <a:prstGeom prst="rect">
             <a:avLst/>
@@ -8973,29 +9248,45 @@
               <a:spcAft>
                 <a:spcPts val="400"/>
               </a:spcAft>
-              <a:defRPr sz="1200" b="0">
-                <a:solidFill>
-                  <a:srgbClr val="526874"/>
-                </a:solidFill>
-                <a:latin typeface="Noto Sans CJK TC"/>
-              </a:defRPr>
-            </a:pPr>
-            <a:r>
-              <a:t>用開市／收市／其他價？資料何時才可用？10:00 初始價如何取得？</a:t>
-            </a:r>
-          </a:p>
-        </p:txBody>
-      </p:sp>
-      <p:sp>
-        <p:nvSpPr>
-          <p:cNvPr id="18" name="Rectangle 17"/>
+              <a:defRPr sz="1150" b="0">
+                <a:solidFill>
+                  <a:srgbClr val="173443"/>
+                </a:solidFill>
+                <a:latin typeface="Noto Sans CJK TC"/>
+              </a:defRPr>
+            </a:pPr>
+            <a:r>
+              <a:t>補取價欄位、時間標籤及資料何時可用；</a:t>
+            </a:r>
+          </a:p>
+          <a:p>
+            <a:pPr>
+              <a:spcAft>
+                <a:spcPts val="400"/>
+              </a:spcAft>
+              <a:defRPr sz="1150" b="0">
+                <a:solidFill>
+                  <a:srgbClr val="173443"/>
+                </a:solidFill>
+                <a:latin typeface="Noto Sans CJK TC"/>
+              </a:defRPr>
+            </a:pPr>
+            <a:r>
+              <a:t>10:00 記價不等於可用該分鐘尚未完成的收市價。</a:t>
+            </a:r>
+          </a:p>
+        </p:txBody>
+      </p:sp>
+      <p:sp>
+        <p:nvSpPr>
+          <p:cNvPr id="22" name="Rectangle 21"/>
           <p:cNvSpPr/>
           <p:nvPr/>
         </p:nvSpPr>
         <p:spPr>
           <a:xfrm>
-            <a:off x="457200" y="2898648"/>
-            <a:ext cx="11247120" cy="466344"/>
+            <a:off x="457200" y="3099815"/>
+            <a:ext cx="11247120" cy="461772"/>
           </a:xfrm>
           <a:prstGeom prst="rect">
             <a:avLst/>
@@ -9032,60 +9323,14 @@
       </p:sp>
       <p:sp>
         <p:nvSpPr>
-          <p:cNvPr id="19" name="Rectangle 18"/>
-          <p:cNvSpPr/>
-          <p:nvPr/>
-        </p:nvSpPr>
-        <p:spPr>
-          <a:xfrm>
-            <a:off x="585216" y="3017520"/>
-            <a:ext cx="155448" cy="155448"/>
-          </a:xfrm>
-          <a:prstGeom prst="rect">
-            <a:avLst/>
-          </a:prstGeom>
-          <a:solidFill>
-            <a:srgbClr val="FFFFFF"/>
-          </a:solidFill>
-          <a:ln>
-            <a:solidFill>
-              <a:srgbClr val="087C83"/>
-            </a:solidFill>
-          </a:ln>
-          <a:effectLst/>
-        </p:spPr>
-        <p:style>
-          <a:lnRef idx="1">
-            <a:schemeClr val="accent1"/>
-          </a:lnRef>
-          <a:fillRef idx="3">
-            <a:schemeClr val="accent1"/>
-          </a:fillRef>
-          <a:effectRef idx="2">
-            <a:schemeClr val="accent1"/>
-          </a:effectRef>
-          <a:fontRef idx="minor">
-            <a:schemeClr val="lt1"/>
-          </a:fontRef>
-        </p:style>
-        <p:txBody>
-          <a:bodyPr rtlCol="0" anchor="ctr"/>
-          <a:lstStyle/>
-          <a:p>
-            <a:pPr algn="ctr"/>
-          </a:p>
-        </p:txBody>
-      </p:sp>
-      <p:sp>
-        <p:nvSpPr>
-          <p:cNvPr id="20" name="TextBox 19"/>
+          <p:cNvPr id="23" name="TextBox 22"/>
           <p:cNvSpPr txBox="1"/>
           <p:nvPr/>
         </p:nvSpPr>
         <p:spPr>
           <a:xfrm>
-            <a:off x="850392" y="2990088"/>
-            <a:ext cx="384048" cy="274320"/>
+            <a:off x="539496" y="3200399"/>
+            <a:ext cx="1609344" cy="274320"/>
           </a:xfrm>
           <a:prstGeom prst="rect">
             <a:avLst/>
@@ -9104,27 +9349,27 @@
               </a:spcAft>
               <a:defRPr sz="1200" b="1">
                 <a:solidFill>
-                  <a:srgbClr val="087C83"/>
-                </a:solidFill>
-                <a:latin typeface="Noto Sans CJK TC"/>
-              </a:defRPr>
-            </a:pPr>
-            <a:r>
-              <a:t>03</a:t>
-            </a:r>
-          </a:p>
-        </p:txBody>
-      </p:sp>
-      <p:sp>
-        <p:nvSpPr>
-          <p:cNvPr id="21" name="TextBox 20"/>
+                  <a:srgbClr val="173443"/>
+                </a:solidFill>
+                <a:latin typeface="Noto Sans CJK TC"/>
+              </a:defRPr>
+            </a:pPr>
+            <a:r>
+              <a:t>03 門檻及錨點</a:t>
+            </a:r>
+          </a:p>
+        </p:txBody>
+      </p:sp>
+      <p:sp>
+        <p:nvSpPr>
+          <p:cNvPr id="24" name="TextBox 23"/>
           <p:cNvSpPr txBox="1"/>
           <p:nvPr/>
         </p:nvSpPr>
         <p:spPr>
           <a:xfrm>
-            <a:off x="1298448" y="2953512"/>
-            <a:ext cx="3108960" cy="356616"/>
+            <a:off x="2267712" y="3122675"/>
+            <a:ext cx="3493008" cy="429768"/>
           </a:xfrm>
           <a:prstGeom prst="rect">
             <a:avLst/>
@@ -9141,29 +9386,45 @@
               <a:spcAft>
                 <a:spcPts val="400"/>
               </a:spcAft>
-              <a:defRPr sz="1500" b="1">
-                <a:solidFill>
-                  <a:srgbClr val="173443"/>
-                </a:solidFill>
-                <a:latin typeface="Noto Sans CJK TC"/>
-              </a:defRPr>
-            </a:pPr>
-            <a:r>
-              <a:t>定義 Renko 門檻及錨點</a:t>
-            </a:r>
-          </a:p>
-        </p:txBody>
-      </p:sp>
-      <p:sp>
-        <p:nvSpPr>
-          <p:cNvPr id="22" name="TextBox 21"/>
+              <a:defRPr sz="1150" b="0">
+                <a:solidFill>
+                  <a:srgbClr val="087C83"/>
+                </a:solidFill>
+                <a:latin typeface="Noto Sans CJK TC"/>
+              </a:defRPr>
+            </a:pPr>
+            <a:r>
+              <a:t>起點 0.5%；開市價換算固定美元；</a:t>
+            </a:r>
+          </a:p>
+          <a:p>
+            <a:pPr>
+              <a:spcAft>
+                <a:spcPts val="400"/>
+              </a:spcAft>
+              <a:defRPr sz="1150" b="0">
+                <a:solidFill>
+                  <a:srgbClr val="087C83"/>
+                </a:solidFill>
+                <a:latin typeface="Noto Sans CJK TC"/>
+              </a:defRPr>
+            </a:pPr>
+            <a:r>
+              <a:t>首事件錨點已有定義。</a:t>
+            </a:r>
+          </a:p>
+        </p:txBody>
+      </p:sp>
+      <p:sp>
+        <p:nvSpPr>
+          <p:cNvPr id="25" name="TextBox 24"/>
           <p:cNvSpPr txBox="1"/>
           <p:nvPr/>
         </p:nvSpPr>
         <p:spPr>
           <a:xfrm>
-            <a:off x="4407408" y="2980944"/>
-            <a:ext cx="7114032" cy="338328"/>
+            <a:off x="5925312" y="3122675"/>
+            <a:ext cx="5669280" cy="429768"/>
           </a:xfrm>
           <a:prstGeom prst="rect">
             <a:avLst/>
@@ -9180,29 +9441,45 @@
               <a:spcAft>
                 <a:spcPts val="400"/>
               </a:spcAft>
-              <a:defRPr sz="1200" b="0">
-                <a:solidFill>
-                  <a:srgbClr val="526874"/>
-                </a:solidFill>
-                <a:latin typeface="Noto Sans CJK TC"/>
-              </a:defRPr>
-            </a:pPr>
-            <a:r>
-              <a:t>美元參考價、後續錨點、重設時點；剛好達標是否計入；百分比是否複利？</a:t>
-            </a:r>
-          </a:p>
-        </p:txBody>
-      </p:sp>
-      <p:sp>
-        <p:nvSpPr>
-          <p:cNvPr id="23" name="Rectangle 22"/>
+              <a:defRPr sz="1150" b="0">
+                <a:solidFill>
+                  <a:srgbClr val="173443"/>
+                </a:solidFill>
+                <a:latin typeface="Noto Sans CJK TC"/>
+              </a:defRPr>
+            </a:pPr>
+            <a:r>
+              <a:t>補開市參考時點、後續錨點、窗口重設、等號；</a:t>
+            </a:r>
+          </a:p>
+          <a:p>
+            <a:pPr>
+              <a:spcAft>
+                <a:spcPts val="400"/>
+              </a:spcAft>
+              <a:defRPr sz="1150" b="0">
+                <a:solidFill>
+                  <a:srgbClr val="173443"/>
+                </a:solidFill>
+                <a:latin typeface="Noto Sans CJK TC"/>
+              </a:defRPr>
+            </a:pPr>
+            <a:r>
+              <a:t>百分比計法有討論，但複利公式仍須統一。</a:t>
+            </a:r>
+          </a:p>
+        </p:txBody>
+      </p:sp>
+      <p:sp>
+        <p:nvSpPr>
+          <p:cNvPr id="26" name="Rectangle 25"/>
           <p:cNvSpPr/>
           <p:nvPr/>
         </p:nvSpPr>
         <p:spPr>
           <a:xfrm>
-            <a:off x="457200" y="3419856"/>
-            <a:ext cx="11247120" cy="466344"/>
+            <a:off x="457200" y="3589020"/>
+            <a:ext cx="11247120" cy="461772"/>
           </a:xfrm>
           <a:prstGeom prst="rect">
             <a:avLst/>
@@ -9239,60 +9516,14 @@
       </p:sp>
       <p:sp>
         <p:nvSpPr>
-          <p:cNvPr id="24" name="Rectangle 23"/>
-          <p:cNvSpPr/>
-          <p:nvPr/>
-        </p:nvSpPr>
-        <p:spPr>
-          <a:xfrm>
-            <a:off x="585216" y="3538727"/>
-            <a:ext cx="155448" cy="155448"/>
-          </a:xfrm>
-          <a:prstGeom prst="rect">
-            <a:avLst/>
-          </a:prstGeom>
-          <a:solidFill>
-            <a:srgbClr val="FFFFFF"/>
-          </a:solidFill>
-          <a:ln>
-            <a:solidFill>
-              <a:srgbClr val="087C83"/>
-            </a:solidFill>
-          </a:ln>
-          <a:effectLst/>
-        </p:spPr>
-        <p:style>
-          <a:lnRef idx="1">
-            <a:schemeClr val="accent1"/>
-          </a:lnRef>
-          <a:fillRef idx="3">
-            <a:schemeClr val="accent1"/>
-          </a:fillRef>
-          <a:effectRef idx="2">
-            <a:schemeClr val="accent1"/>
-          </a:effectRef>
-          <a:fontRef idx="minor">
-            <a:schemeClr val="lt1"/>
-          </a:fontRef>
-        </p:style>
-        <p:txBody>
-          <a:bodyPr rtlCol="0" anchor="ctr"/>
-          <a:lstStyle/>
-          <a:p>
-            <a:pPr algn="ctr"/>
-          </a:p>
-        </p:txBody>
-      </p:sp>
-      <p:sp>
-        <p:nvSpPr>
-          <p:cNvPr id="25" name="TextBox 24"/>
+          <p:cNvPr id="27" name="TextBox 26"/>
           <p:cNvSpPr txBox="1"/>
           <p:nvPr/>
         </p:nvSpPr>
         <p:spPr>
           <a:xfrm>
-            <a:off x="850392" y="3511296"/>
-            <a:ext cx="384048" cy="274320"/>
+            <a:off x="539496" y="3689604"/>
+            <a:ext cx="1609344" cy="274320"/>
           </a:xfrm>
           <a:prstGeom prst="rect">
             <a:avLst/>
@@ -9311,27 +9542,27 @@
               </a:spcAft>
               <a:defRPr sz="1200" b="1">
                 <a:solidFill>
-                  <a:srgbClr val="087C83"/>
-                </a:solidFill>
-                <a:latin typeface="Noto Sans CJK TC"/>
-              </a:defRPr>
-            </a:pPr>
-            <a:r>
-              <a:t>04</a:t>
-            </a:r>
-          </a:p>
-        </p:txBody>
-      </p:sp>
-      <p:sp>
-        <p:nvSpPr>
-          <p:cNvPr id="26" name="TextBox 25"/>
+                  <a:srgbClr val="173443"/>
+                </a:solidFill>
+                <a:latin typeface="Noto Sans CJK TC"/>
+              </a:defRPr>
+            </a:pPr>
+            <a:r>
+              <a:t>04 B／R 計數</a:t>
+            </a:r>
+          </a:p>
+        </p:txBody>
+      </p:sp>
+      <p:sp>
+        <p:nvSpPr>
+          <p:cNvPr id="28" name="TextBox 27"/>
           <p:cNvSpPr txBox="1"/>
           <p:nvPr/>
         </p:nvSpPr>
         <p:spPr>
           <a:xfrm>
-            <a:off x="1298448" y="3474720"/>
-            <a:ext cx="3108960" cy="356616"/>
+            <a:off x="2267712" y="3611879"/>
+            <a:ext cx="3493008" cy="429768"/>
           </a:xfrm>
           <a:prstGeom prst="rect">
             <a:avLst/>
@@ -9348,29 +9579,45 @@
               <a:spcAft>
                 <a:spcPts val="400"/>
               </a:spcAft>
-              <a:defRPr sz="1500" b="1">
-                <a:solidFill>
-                  <a:srgbClr val="173443"/>
-                </a:solidFill>
-                <a:latin typeface="Noto Sans CJK TC"/>
-              </a:defRPr>
-            </a:pPr>
-            <a:r>
-              <a:t>定義 B／R 及跨門檻計數</a:t>
-            </a:r>
-          </a:p>
-        </p:txBody>
-      </p:sp>
-      <p:sp>
-        <p:nvSpPr>
-          <p:cNvPr id="27" name="TextBox 26"/>
+              <a:defRPr sz="1150" b="0">
+                <a:solidFill>
+                  <a:srgbClr val="087C83"/>
+                </a:solidFill>
+                <a:latin typeface="Noto Sans CJK TC"/>
+              </a:defRPr>
+            </a:pPr>
+            <a:r>
+              <a:t>B：價格變動門檻事件；</a:t>
+            </a:r>
+          </a:p>
+          <a:p>
+            <a:pPr>
+              <a:spcAft>
+                <a:spcPts val="400"/>
+              </a:spcAft>
+              <a:defRPr sz="1150" b="0">
+                <a:solidFill>
+                  <a:srgbClr val="087C83"/>
+                </a:solidFill>
+                <a:latin typeface="Noto Sans CJK TC"/>
+              </a:defRPr>
+            </a:pPr>
+            <a:r>
+              <a:t>R：升轉跌／跌轉升。</a:t>
+            </a:r>
+          </a:p>
+        </p:txBody>
+      </p:sp>
+      <p:sp>
+        <p:nvSpPr>
+          <p:cNvPr id="29" name="TextBox 28"/>
           <p:cNvSpPr txBox="1"/>
           <p:nvPr/>
         </p:nvSpPr>
         <p:spPr>
           <a:xfrm>
-            <a:off x="4407408" y="3502151"/>
-            <a:ext cx="7114032" cy="338328"/>
+            <a:off x="5925312" y="3611879"/>
+            <a:ext cx="5669280" cy="429768"/>
           </a:xfrm>
           <a:prstGeom prst="rect">
             <a:avLst/>
@@ -9387,29 +9634,45 @@
               <a:spcAft>
                 <a:spcPts val="400"/>
               </a:spcAft>
-              <a:defRPr sz="1200" b="0">
-                <a:solidFill>
-                  <a:srgbClr val="526874"/>
-                </a:solidFill>
-                <a:latin typeface="Noto Sans CJK TC"/>
-              </a:defRPr>
-            </a:pPr>
-            <a:r>
-              <a:t>一分鐘跨多級計幾次？首事件、方向轉換及同分鐘可產生幾次交易動作？</a:t>
-            </a:r>
-          </a:p>
-        </p:txBody>
-      </p:sp>
-      <p:sp>
-        <p:nvSpPr>
-          <p:cNvPr id="28" name="Rectangle 27"/>
+              <a:defRPr sz="1150" b="0">
+                <a:solidFill>
+                  <a:srgbClr val="173443"/>
+                </a:solidFill>
+                <a:latin typeface="Noto Sans CJK TC"/>
+              </a:defRPr>
+            </a:pPr>
+            <a:r>
+              <a:t>補一分鐘跨多級計幾次、首事件及統計窗口邊界；</a:t>
+            </a:r>
+          </a:p>
+          <a:p>
+            <a:pPr>
+              <a:spcAft>
+                <a:spcPts val="400"/>
+              </a:spcAft>
+              <a:defRPr sz="1150" b="0">
+                <a:solidFill>
+                  <a:srgbClr val="173443"/>
+                </a:solidFill>
+                <a:latin typeface="Noto Sans CJK TC"/>
+              </a:defRPr>
+            </a:pPr>
+            <a:r>
+              <a:t>分開事件數與同分鐘可執行的交易動作數。</a:t>
+            </a:r>
+          </a:p>
+        </p:txBody>
+      </p:sp>
+      <p:sp>
+        <p:nvSpPr>
+          <p:cNvPr id="30" name="Rectangle 29"/>
           <p:cNvSpPr/>
           <p:nvPr/>
         </p:nvSpPr>
         <p:spPr>
           <a:xfrm>
-            <a:off x="457200" y="3941063"/>
-            <a:ext cx="11247120" cy="466344"/>
+            <a:off x="457200" y="4078224"/>
+            <a:ext cx="11247120" cy="461772"/>
           </a:xfrm>
           <a:prstGeom prst="rect">
             <a:avLst/>
@@ -9446,60 +9709,14 @@
       </p:sp>
       <p:sp>
         <p:nvSpPr>
-          <p:cNvPr id="29" name="Rectangle 28"/>
-          <p:cNvSpPr/>
-          <p:nvPr/>
-        </p:nvSpPr>
-        <p:spPr>
-          <a:xfrm>
-            <a:off x="585216" y="4059935"/>
-            <a:ext cx="155448" cy="155448"/>
-          </a:xfrm>
-          <a:prstGeom prst="rect">
-            <a:avLst/>
-          </a:prstGeom>
-          <a:solidFill>
-            <a:srgbClr val="FFFFFF"/>
-          </a:solidFill>
-          <a:ln>
-            <a:solidFill>
-              <a:srgbClr val="087C83"/>
-            </a:solidFill>
-          </a:ln>
-          <a:effectLst/>
-        </p:spPr>
-        <p:style>
-          <a:lnRef idx="1">
-            <a:schemeClr val="accent1"/>
-          </a:lnRef>
-          <a:fillRef idx="3">
-            <a:schemeClr val="accent1"/>
-          </a:fillRef>
-          <a:effectRef idx="2">
-            <a:schemeClr val="accent1"/>
-          </a:effectRef>
-          <a:fontRef idx="minor">
-            <a:schemeClr val="lt1"/>
-          </a:fontRef>
-        </p:style>
-        <p:txBody>
-          <a:bodyPr rtlCol="0" anchor="ctr"/>
-          <a:lstStyle/>
-          <a:p>
-            <a:pPr algn="ctr"/>
-          </a:p>
-        </p:txBody>
-      </p:sp>
-      <p:sp>
-        <p:nvSpPr>
-          <p:cNvPr id="30" name="TextBox 29"/>
+          <p:cNvPr id="31" name="TextBox 30"/>
           <p:cNvSpPr txBox="1"/>
           <p:nvPr/>
         </p:nvSpPr>
         <p:spPr>
           <a:xfrm>
-            <a:off x="850392" y="4032503"/>
-            <a:ext cx="384048" cy="274320"/>
+            <a:off x="539496" y="4178808"/>
+            <a:ext cx="1609344" cy="274320"/>
           </a:xfrm>
           <a:prstGeom prst="rect">
             <a:avLst/>
@@ -9518,27 +9735,27 @@
               </a:spcAft>
               <a:defRPr sz="1200" b="1">
                 <a:solidFill>
-                  <a:srgbClr val="087C83"/>
-                </a:solidFill>
-                <a:latin typeface="Noto Sans CJK TC"/>
-              </a:defRPr>
-            </a:pPr>
-            <a:r>
-              <a:t>05</a:t>
-            </a:r>
-          </a:p>
-        </p:txBody>
-      </p:sp>
-      <p:sp>
-        <p:nvSpPr>
-          <p:cNvPr id="31" name="TextBox 30"/>
+                  <a:srgbClr val="173443"/>
+                </a:solidFill>
+                <a:latin typeface="Noto Sans CJK TC"/>
+              </a:defRPr>
+            </a:pPr>
+            <a:r>
+              <a:t>05 股票池計算</a:t>
+            </a:r>
+          </a:p>
+        </p:txBody>
+      </p:sp>
+      <p:sp>
+        <p:nvSpPr>
+          <p:cNvPr id="32" name="TextBox 31"/>
           <p:cNvSpPr txBox="1"/>
           <p:nvPr/>
         </p:nvSpPr>
         <p:spPr>
           <a:xfrm>
-            <a:off x="1298448" y="3995927"/>
-            <a:ext cx="3108960" cy="356616"/>
+            <a:off x="2267712" y="4101084"/>
+            <a:ext cx="3493008" cy="429768"/>
           </a:xfrm>
           <a:prstGeom prst="rect">
             <a:avLst/>
@@ -9555,29 +9772,45 @@
               <a:spcAft>
                 <a:spcPts val="400"/>
               </a:spcAft>
-              <a:defRPr sz="1500" b="1">
-                <a:solidFill>
-                  <a:srgbClr val="173443"/>
-                </a:solidFill>
-                <a:latin typeface="Noto Sans CJK TC"/>
-              </a:defRPr>
-            </a:pPr>
-            <a:r>
-              <a:t>定義股票池四項計算</a:t>
-            </a:r>
-          </a:p>
-        </p:txBody>
-      </p:sp>
-      <p:sp>
-        <p:nvSpPr>
-          <p:cNvPr id="32" name="TextBox 31"/>
+              <a:defRPr sz="1150" b="0">
+                <a:solidFill>
+                  <a:srgbClr val="087C83"/>
+                </a:solidFill>
+                <a:latin typeface="Noto Sans CJK TC"/>
+              </a:defRPr>
+            </a:pPr>
+            <a:r>
+              <a:t>20 日平均及四項數值已有；</a:t>
+            </a:r>
+          </a:p>
+          <a:p>
+            <a:pPr>
+              <a:spcAft>
+                <a:spcPts val="400"/>
+              </a:spcAft>
+              <a:defRPr sz="1150" b="0">
+                <a:solidFill>
+                  <a:srgbClr val="087C83"/>
+                </a:solidFill>
+                <a:latin typeface="Noto Sans CJK TC"/>
+              </a:defRPr>
+            </a:pPr>
+            <a:r>
+              <a:t>波幅分子為最高價減最低價。</a:t>
+            </a:r>
+          </a:p>
+        </p:txBody>
+      </p:sp>
+      <p:sp>
+        <p:nvSpPr>
+          <p:cNvPr id="33" name="TextBox 32"/>
           <p:cNvSpPr txBox="1"/>
           <p:nvPr/>
         </p:nvSpPr>
         <p:spPr>
           <a:xfrm>
-            <a:off x="4407408" y="4023359"/>
-            <a:ext cx="7114032" cy="338328"/>
+            <a:off x="5925312" y="4101084"/>
+            <a:ext cx="5669280" cy="429768"/>
           </a:xfrm>
           <a:prstGeom prst="rect">
             <a:avLst/>
@@ -9594,29 +9827,45 @@
               <a:spcAft>
                 <a:spcPts val="400"/>
               </a:spcAft>
-              <a:defRPr sz="1200" b="0">
-                <a:solidFill>
-                  <a:srgbClr val="526874"/>
-                </a:solidFill>
-                <a:latin typeface="Noto Sans CJK TC"/>
-              </a:defRPr>
-            </a:pPr>
-            <a:r>
-              <a:t>20 日是交易日還是曆日？平均股價用甚麼價？波幅百分比分母用甚麼？</a:t>
-            </a:r>
-          </a:p>
-        </p:txBody>
-      </p:sp>
-      <p:sp>
-        <p:nvSpPr>
-          <p:cNvPr id="33" name="Rectangle 32"/>
+              <a:defRPr sz="1150" b="0">
+                <a:solidFill>
+                  <a:srgbClr val="173443"/>
+                </a:solidFill>
+                <a:latin typeface="Noto Sans CJK TC"/>
+              </a:defRPr>
+            </a:pPr>
+            <a:r>
+              <a:t>只補交易日／曆日、平均取價、波幅分母及平均法；</a:t>
+            </a:r>
+          </a:p>
+          <a:p>
+            <a:pPr>
+              <a:spcAft>
+                <a:spcPts val="400"/>
+              </a:spcAft>
+              <a:defRPr sz="1150" b="0">
+                <a:solidFill>
+                  <a:srgbClr val="173443"/>
+                </a:solidFill>
+                <a:latin typeface="Noto Sans CJK TC"/>
+              </a:defRPr>
+            </a:pPr>
+            <a:r>
+              <a:t>價格上下限端點與回看不足亦須有規則。</a:t>
+            </a:r>
+          </a:p>
+        </p:txBody>
+      </p:sp>
+      <p:sp>
+        <p:nvSpPr>
+          <p:cNvPr id="34" name="Rectangle 33"/>
           <p:cNvSpPr/>
           <p:nvPr/>
         </p:nvSpPr>
         <p:spPr>
           <a:xfrm>
-            <a:off x="457200" y="4462271"/>
-            <a:ext cx="11247120" cy="466344"/>
+            <a:off x="457200" y="4567428"/>
+            <a:ext cx="11247120" cy="461772"/>
           </a:xfrm>
           <a:prstGeom prst="rect">
             <a:avLst/>
@@ -9653,60 +9902,14 @@
       </p:sp>
       <p:sp>
         <p:nvSpPr>
-          <p:cNvPr id="34" name="Rectangle 33"/>
-          <p:cNvSpPr/>
-          <p:nvPr/>
-        </p:nvSpPr>
-        <p:spPr>
-          <a:xfrm>
-            <a:off x="585216" y="4581143"/>
-            <a:ext cx="155448" cy="155448"/>
-          </a:xfrm>
-          <a:prstGeom prst="rect">
-            <a:avLst/>
-          </a:prstGeom>
-          <a:solidFill>
-            <a:srgbClr val="FFFFFF"/>
-          </a:solidFill>
-          <a:ln>
-            <a:solidFill>
-              <a:srgbClr val="087C83"/>
-            </a:solidFill>
-          </a:ln>
-          <a:effectLst/>
-        </p:spPr>
-        <p:style>
-          <a:lnRef idx="1">
-            <a:schemeClr val="accent1"/>
-          </a:lnRef>
-          <a:fillRef idx="3">
-            <a:schemeClr val="accent1"/>
-          </a:fillRef>
-          <a:effectRef idx="2">
-            <a:schemeClr val="accent1"/>
-          </a:effectRef>
-          <a:fontRef idx="minor">
-            <a:schemeClr val="lt1"/>
-          </a:fontRef>
-        </p:style>
-        <p:txBody>
-          <a:bodyPr rtlCol="0" anchor="ctr"/>
-          <a:lstStyle/>
-          <a:p>
-            <a:pPr algn="ctr"/>
-          </a:p>
-        </p:txBody>
-      </p:sp>
-      <p:sp>
-        <p:nvSpPr>
           <p:cNvPr id="35" name="TextBox 34"/>
           <p:cNvSpPr txBox="1"/>
           <p:nvPr/>
         </p:nvSpPr>
         <p:spPr>
           <a:xfrm>
-            <a:off x="850392" y="4553711"/>
-            <a:ext cx="384048" cy="274320"/>
+            <a:off x="539496" y="4668012"/>
+            <a:ext cx="1609344" cy="274320"/>
           </a:xfrm>
           <a:prstGeom prst="rect">
             <a:avLst/>
@@ -9725,13 +9928,13 @@
               </a:spcAft>
               <a:defRPr sz="1200" b="1">
                 <a:solidFill>
-                  <a:srgbClr val="087C83"/>
-                </a:solidFill>
-                <a:latin typeface="Noto Sans CJK TC"/>
-              </a:defRPr>
-            </a:pPr>
-            <a:r>
-              <a:t>06</a:t>
+                  <a:srgbClr val="173443"/>
+                </a:solidFill>
+                <a:latin typeface="Noto Sans CJK TC"/>
+              </a:defRPr>
+            </a:pPr>
+            <a:r>
+              <a:t>06 資料供應</a:t>
             </a:r>
           </a:p>
         </p:txBody>
@@ -9744,8 +9947,8 @@
         </p:nvSpPr>
         <p:spPr>
           <a:xfrm>
-            <a:off x="1298448" y="4517135"/>
-            <a:ext cx="3108960" cy="356616"/>
+            <a:off x="2267712" y="4590288"/>
+            <a:ext cx="3493008" cy="429768"/>
           </a:xfrm>
           <a:prstGeom prst="rect">
             <a:avLst/>
@@ -9762,15 +9965,31 @@
               <a:spcAft>
                 <a:spcPts val="400"/>
               </a:spcAft>
-              <a:defRPr sz="1500" b="1">
-                <a:solidFill>
-                  <a:srgbClr val="173443"/>
-                </a:solidFill>
-                <a:latin typeface="Noto Sans CJK TC"/>
-              </a:defRPr>
-            </a:pPr>
-            <a:r>
-              <a:t>確認股票池及資料供應</a:t>
+              <a:defRPr sz="1150" b="0">
+                <a:solidFill>
+                  <a:srgbClr val="087C83"/>
+                </a:solidFill>
+                <a:latin typeface="Noto Sans CJK TC"/>
+              </a:defRPr>
+            </a:pPr>
+            <a:r>
+              <a:t>以 IB 平台股票池作起點；</a:t>
+            </a:r>
+          </a:p>
+          <a:p>
+            <a:pPr>
+              <a:spcAft>
+                <a:spcPts val="400"/>
+              </a:spcAft>
+              <a:defRPr sz="1150" b="0">
+                <a:solidFill>
+                  <a:srgbClr val="087C83"/>
+                </a:solidFill>
+                <a:latin typeface="Noto Sans CJK TC"/>
+              </a:defRPr>
+            </a:pPr>
+            <a:r>
+              <a:t>歷史資料及一分鐘取樣框架已有。</a:t>
             </a:r>
           </a:p>
         </p:txBody>
@@ -9783,8 +10002,8 @@
         </p:nvSpPr>
         <p:spPr>
           <a:xfrm>
-            <a:off x="4407408" y="4544567"/>
-            <a:ext cx="7114032" cy="338328"/>
+            <a:off x="5925312" y="4590288"/>
+            <a:ext cx="5669280" cy="429768"/>
           </a:xfrm>
           <a:prstGeom prst="rect">
             <a:avLst/>
@@ -9801,15 +10020,31 @@
               <a:spcAft>
                 <a:spcPts val="400"/>
               </a:spcAft>
-              <a:defRPr sz="1200" b="0">
-                <a:solidFill>
-                  <a:srgbClr val="526874"/>
-                </a:solidFill>
-                <a:latin typeface="Noto Sans CJK TC"/>
-              </a:defRPr>
-            </a:pPr>
-            <a:r>
-              <a:t>可交易證券範圍、歷史市值／分鐘線來源、授權、資料預算及保留方式。</a:t>
+              <a:defRPr sz="1150" b="0">
+                <a:solidFill>
+                  <a:srgbClr val="173443"/>
+                </a:solidFill>
+                <a:latin typeface="Noto Sans CJK TC"/>
+              </a:defRPr>
+            </a:pPr>
+            <a:r>
+              <a:t>落實證券範圍、實際歷史供應商、授權及預算；</a:t>
+            </a:r>
+          </a:p>
+          <a:p>
+            <a:pPr>
+              <a:spcAft>
+                <a:spcPts val="400"/>
+              </a:spcAft>
+              <a:defRPr sz="1150" b="0">
+                <a:solidFill>
+                  <a:srgbClr val="173443"/>
+                </a:solidFill>
+                <a:latin typeface="Noto Sans CJK TC"/>
+              </a:defRPr>
+            </a:pPr>
+            <a:r>
+              <a:t>提到 IB 不等於已確認全部資料由 IB 提供。</a:t>
             </a:r>
           </a:p>
         </p:txBody>
@@ -9822,8 +10057,8 @@
         </p:nvSpPr>
         <p:spPr>
           <a:xfrm>
-            <a:off x="457200" y="4983479"/>
-            <a:ext cx="11247120" cy="466344"/>
+            <a:off x="457200" y="5056631"/>
+            <a:ext cx="11247120" cy="461772"/>
           </a:xfrm>
           <a:prstGeom prst="rect">
             <a:avLst/>
@@ -9860,47 +10095,40 @@
       </p:sp>
       <p:sp>
         <p:nvSpPr>
-          <p:cNvPr id="39" name="Rectangle 38"/>
-          <p:cNvSpPr/>
-          <p:nvPr/>
-        </p:nvSpPr>
-        <p:spPr>
-          <a:xfrm>
-            <a:off x="585216" y="5102351"/>
-            <a:ext cx="155448" cy="155448"/>
-          </a:xfrm>
-          <a:prstGeom prst="rect">
-            <a:avLst/>
-          </a:prstGeom>
-          <a:solidFill>
-            <a:srgbClr val="FFFFFF"/>
-          </a:solidFill>
-          <a:ln>
-            <a:solidFill>
-              <a:srgbClr val="087C83"/>
-            </a:solidFill>
-          </a:ln>
-          <a:effectLst/>
-        </p:spPr>
-        <p:style>
-          <a:lnRef idx="1">
-            <a:schemeClr val="accent1"/>
-          </a:lnRef>
-          <a:fillRef idx="3">
-            <a:schemeClr val="accent1"/>
-          </a:fillRef>
-          <a:effectRef idx="2">
-            <a:schemeClr val="accent1"/>
-          </a:effectRef>
-          <a:fontRef idx="minor">
-            <a:schemeClr val="lt1"/>
-          </a:fontRef>
-        </p:style>
-        <p:txBody>
-          <a:bodyPr rtlCol="0" anchor="ctr"/>
-          <a:lstStyle/>
-          <a:p>
-            <a:pPr algn="ctr"/>
+          <p:cNvPr id="39" name="TextBox 38"/>
+          <p:cNvSpPr txBox="1"/>
+          <p:nvPr/>
+        </p:nvSpPr>
+        <p:spPr>
+          <a:xfrm>
+            <a:off x="539496" y="5157216"/>
+            <a:ext cx="1609344" cy="274320"/>
+          </a:xfrm>
+          <a:prstGeom prst="rect">
+            <a:avLst/>
+          </a:prstGeom>
+          <a:noFill/>
+        </p:spPr>
+        <p:txBody>
+          <a:bodyPr wrap="square" lIns="9144" rIns="9144" tIns="0" bIns="0">
+            <a:spAutoFit/>
+          </a:bodyPr>
+          <a:lstStyle/>
+          <a:p>
+            <a:pPr>
+              <a:spcAft>
+                <a:spcPts val="400"/>
+              </a:spcAft>
+              <a:defRPr sz="1200" b="1">
+                <a:solidFill>
+                  <a:srgbClr val="173443"/>
+                </a:solidFill>
+                <a:latin typeface="Noto Sans CJK TC"/>
+              </a:defRPr>
+            </a:pPr>
+            <a:r>
+              <a:t>07 異常處理</a:t>
+            </a:r>
           </a:p>
         </p:txBody>
       </p:sp>
@@ -9912,8 +10140,8 @@
         </p:nvSpPr>
         <p:spPr>
           <a:xfrm>
-            <a:off x="850392" y="5074919"/>
-            <a:ext cx="384048" cy="274320"/>
+            <a:off x="2267712" y="5079492"/>
+            <a:ext cx="3493008" cy="429768"/>
           </a:xfrm>
           <a:prstGeom prst="rect">
             <a:avLst/>
@@ -9930,7 +10158,7 @@
               <a:spcAft>
                 <a:spcPts val="400"/>
               </a:spcAft>
-              <a:defRPr sz="1200" b="1">
+              <a:defRPr sz="1150" b="0">
                 <a:solidFill>
                   <a:srgbClr val="087C83"/>
                 </a:solidFill>
@@ -9938,7 +10166,23 @@
               </a:defRPr>
             </a:pPr>
             <a:r>
-              <a:t>07</a:t>
+              <a:t>目前兩份逐字稿及五張原圖，</a:t>
+            </a:r>
+          </a:p>
+          <a:p>
+            <a:pPr>
+              <a:spcAft>
+                <a:spcPts val="400"/>
+              </a:spcAft>
+              <a:defRPr sz="1150" b="0">
+                <a:solidFill>
+                  <a:srgbClr val="087C83"/>
+                </a:solidFill>
+                <a:latin typeface="Noto Sans CJK TC"/>
+              </a:defRPr>
+            </a:pPr>
+            <a:r>
+              <a:t>未找到完整指定處理政策。</a:t>
             </a:r>
           </a:p>
         </p:txBody>
@@ -9951,8 +10195,8 @@
         </p:nvSpPr>
         <p:spPr>
           <a:xfrm>
-            <a:off x="1298448" y="5038343"/>
-            <a:ext cx="3108960" cy="356616"/>
+            <a:off x="5925312" y="5079492"/>
+            <a:ext cx="5669280" cy="429768"/>
           </a:xfrm>
           <a:prstGeom prst="rect">
             <a:avLst/>
@@ -9969,7 +10213,7 @@
               <a:spcAft>
                 <a:spcPts val="400"/>
               </a:spcAft>
-              <a:defRPr sz="1500" b="1">
+              <a:defRPr sz="1150" b="0">
                 <a:solidFill>
                   <a:srgbClr val="173443"/>
                 </a:solidFill>
@@ -9977,60 +10221,37 @@
               </a:defRPr>
             </a:pPr>
             <a:r>
-              <a:t>定義異常及公司行動處理</a:t>
-            </a:r>
-          </a:p>
-        </p:txBody>
-      </p:sp>
-      <p:sp>
-        <p:nvSpPr>
-          <p:cNvPr id="42" name="TextBox 41"/>
-          <p:cNvSpPr txBox="1"/>
-          <p:nvPr/>
-        </p:nvSpPr>
-        <p:spPr>
-          <a:xfrm>
-            <a:off x="4407408" y="5065775"/>
-            <a:ext cx="7114032" cy="338328"/>
-          </a:xfrm>
-          <a:prstGeom prst="rect">
-            <a:avLst/>
-          </a:prstGeom>
-          <a:noFill/>
-        </p:spPr>
-        <p:txBody>
-          <a:bodyPr wrap="square" lIns="9144" rIns="9144" tIns="0" bIns="0">
-            <a:spAutoFit/>
-          </a:bodyPr>
-          <a:lstStyle/>
-          <a:p>
-            <a:pPr>
-              <a:spcAft>
-                <a:spcPts val="400"/>
-              </a:spcAft>
-              <a:defRPr sz="1200" b="0">
-                <a:solidFill>
-                  <a:srgbClr val="526874"/>
-                </a:solidFill>
-                <a:latin typeface="Noto Sans CJK TC"/>
-              </a:defRPr>
-            </a:pPr>
-            <a:r>
-              <a:t>缺分鐘、停牌、拆股、改名、新上市／退市、回看期不足及資料遲公布怎樣處理？</a:t>
-            </a:r>
-          </a:p>
-        </p:txBody>
-      </p:sp>
-      <p:sp>
-        <p:nvSpPr>
-          <p:cNvPr id="43" name="Rectangle 42"/>
+              <a:t>補缺資料、停牌、拆股、改名、上市／退市、遲公布；</a:t>
+            </a:r>
+          </a:p>
+          <a:p>
+            <a:pPr>
+              <a:spcAft>
+                <a:spcPts val="400"/>
+              </a:spcAft>
+              <a:defRPr sz="1150" b="0">
+                <a:solidFill>
+                  <a:srgbClr val="173443"/>
+                </a:solidFill>
+                <a:latin typeface="Noto Sans CJK TC"/>
+              </a:defRPr>
+            </a:pPr>
+            <a:r>
+              <a:t>舊稿的工程建議不能當成會議已批准規則。</a:t>
+            </a:r>
+          </a:p>
+        </p:txBody>
+      </p:sp>
+      <p:sp>
+        <p:nvSpPr>
+          <p:cNvPr id="42" name="Rectangle 41"/>
           <p:cNvSpPr/>
           <p:nvPr/>
         </p:nvSpPr>
         <p:spPr>
           <a:xfrm>
-            <a:off x="457200" y="5504688"/>
-            <a:ext cx="11247120" cy="466344"/>
+            <a:off x="457200" y="5545836"/>
+            <a:ext cx="11247120" cy="461772"/>
           </a:xfrm>
           <a:prstGeom prst="rect">
             <a:avLst/>
@@ -10067,47 +10288,95 @@
       </p:sp>
       <p:sp>
         <p:nvSpPr>
-          <p:cNvPr id="44" name="Rectangle 43"/>
-          <p:cNvSpPr/>
-          <p:nvPr/>
-        </p:nvSpPr>
-        <p:spPr>
-          <a:xfrm>
-            <a:off x="585216" y="5623559"/>
-            <a:ext cx="155448" cy="155448"/>
-          </a:xfrm>
-          <a:prstGeom prst="rect">
-            <a:avLst/>
-          </a:prstGeom>
-          <a:solidFill>
-            <a:srgbClr val="FFFFFF"/>
-          </a:solidFill>
-          <a:ln>
-            <a:solidFill>
-              <a:srgbClr val="087C83"/>
-            </a:solidFill>
-          </a:ln>
-          <a:effectLst/>
-        </p:spPr>
-        <p:style>
-          <a:lnRef idx="1">
-            <a:schemeClr val="accent1"/>
-          </a:lnRef>
-          <a:fillRef idx="3">
-            <a:schemeClr val="accent1"/>
-          </a:fillRef>
-          <a:effectRef idx="2">
-            <a:schemeClr val="accent1"/>
-          </a:effectRef>
-          <a:fontRef idx="minor">
-            <a:schemeClr val="lt1"/>
-          </a:fontRef>
-        </p:style>
-        <p:txBody>
-          <a:bodyPr rtlCol="0" anchor="ctr"/>
-          <a:lstStyle/>
-          <a:p>
-            <a:pPr algn="ctr"/>
+          <p:cNvPr id="43" name="TextBox 42"/>
+          <p:cNvSpPr txBox="1"/>
+          <p:nvPr/>
+        </p:nvSpPr>
+        <p:spPr>
+          <a:xfrm>
+            <a:off x="539496" y="5646420"/>
+            <a:ext cx="1609344" cy="274320"/>
+          </a:xfrm>
+          <a:prstGeom prst="rect">
+            <a:avLst/>
+          </a:prstGeom>
+          <a:noFill/>
+        </p:spPr>
+        <p:txBody>
+          <a:bodyPr wrap="square" lIns="9144" rIns="9144" tIns="0" bIns="0">
+            <a:spAutoFit/>
+          </a:bodyPr>
+          <a:lstStyle/>
+          <a:p>
+            <a:pPr>
+              <a:spcAft>
+                <a:spcPts val="400"/>
+              </a:spcAft>
+              <a:defRPr sz="1200" b="1">
+                <a:solidFill>
+                  <a:srgbClr val="173443"/>
+                </a:solidFill>
+                <a:latin typeface="Noto Sans CJK TC"/>
+              </a:defRPr>
+            </a:pPr>
+            <a:r>
+              <a:t>08 名單及配注</a:t>
+            </a:r>
+          </a:p>
+        </p:txBody>
+      </p:sp>
+      <p:sp>
+        <p:nvSpPr>
+          <p:cNvPr id="44" name="TextBox 43"/>
+          <p:cNvSpPr txBox="1"/>
+          <p:nvPr/>
+        </p:nvSpPr>
+        <p:spPr>
+          <a:xfrm>
+            <a:off x="2267712" y="5568696"/>
+            <a:ext cx="3493008" cy="429768"/>
+          </a:xfrm>
+          <a:prstGeom prst="rect">
+            <a:avLst/>
+          </a:prstGeom>
+          <a:noFill/>
+        </p:spPr>
+        <p:txBody>
+          <a:bodyPr wrap="square" lIns="9144" rIns="9144" tIns="0" bIns="0">
+            <a:spAutoFit/>
+          </a:bodyPr>
+          <a:lstStyle/>
+          <a:p>
+            <a:pPr>
+              <a:spcAft>
+                <a:spcPts val="400"/>
+              </a:spcAft>
+              <a:defRPr sz="1150" b="0">
+                <a:solidFill>
+                  <a:srgbClr val="087C83"/>
+                </a:solidFill>
+                <a:latin typeface="Noto Sans CJK TC"/>
+              </a:defRPr>
+            </a:pPr>
+            <a:r>
+              <a:t>早／午各按 RR 揀 10 隻，可重複；</a:t>
+            </a:r>
+          </a:p>
+          <a:p>
+            <a:pPr>
+              <a:spcAft>
+                <a:spcPts val="400"/>
+              </a:spcAft>
+              <a:defRPr sz="1150" b="0">
+                <a:solidFill>
+                  <a:srgbClr val="087C83"/>
+                </a:solidFill>
+                <a:latin typeface="Noto Sans CJK TC"/>
+              </a:defRPr>
+            </a:pPr>
+            <a:r>
+              <a:t>整數股數最接近 1,000 美元，可略超。</a:t>
+            </a:r>
           </a:p>
         </p:txBody>
       </p:sp>
@@ -10119,8 +10388,8 @@
         </p:nvSpPr>
         <p:spPr>
           <a:xfrm>
-            <a:off x="850392" y="5596127"/>
-            <a:ext cx="384048" cy="274320"/>
+            <a:off x="5925312" y="5568696"/>
+            <a:ext cx="5669280" cy="429768"/>
           </a:xfrm>
           <a:prstGeom prst="rect">
             <a:avLst/>
@@ -10137,15 +10406,31 @@
               <a:spcAft>
                 <a:spcPts val="400"/>
               </a:spcAft>
-              <a:defRPr sz="1200" b="1">
-                <a:solidFill>
-                  <a:srgbClr val="087C83"/>
-                </a:solidFill>
-                <a:latin typeface="Noto Sans CJK TC"/>
-              </a:defRPr>
-            </a:pPr>
-            <a:r>
-              <a:t>08</a:t>
+              <a:defRPr sz="1150" b="0">
+                <a:solidFill>
+                  <a:srgbClr val="173443"/>
+                </a:solidFill>
+                <a:latin typeface="Noto Sans CJK TC"/>
+              </a:defRPr>
+            </a:pPr>
+            <a:r>
+              <a:t>只補同分、不足候選、參考價、同距及何時重算；</a:t>
+            </a:r>
+          </a:p>
+          <a:p>
+            <a:pPr>
+              <a:spcAft>
+                <a:spcPts val="400"/>
+              </a:spcAft>
+              <a:defRPr sz="1150" b="0">
+                <a:solidFill>
+                  <a:srgbClr val="173443"/>
+                </a:solidFill>
+                <a:latin typeface="Noto Sans CJK TC"/>
+              </a:defRPr>
+            </a:pPr>
+            <a:r>
+              <a:t>前日收市後準備，不等於指定用前收市價。</a:t>
             </a:r>
           </a:p>
         </p:txBody>
@@ -10158,8 +10443,8 @@
         </p:nvSpPr>
         <p:spPr>
           <a:xfrm>
-            <a:off x="1298448" y="5559551"/>
-            <a:ext cx="3108960" cy="356616"/>
+            <a:off x="502920" y="6126480"/>
+            <a:ext cx="11064240" cy="219456"/>
           </a:xfrm>
           <a:prstGeom prst="rect">
             <a:avLst/>
@@ -10176,85 +10461,7 @@
               <a:spcAft>
                 <a:spcPts val="400"/>
               </a:spcAft>
-              <a:defRPr sz="1500" b="1">
-                <a:solidFill>
-                  <a:srgbClr val="173443"/>
-                </a:solidFill>
-                <a:latin typeface="Noto Sans CJK TC"/>
-              </a:defRPr>
-            </a:pPr>
-            <a:r>
-              <a:t>定義名單及配注細則</a:t>
-            </a:r>
-          </a:p>
-        </p:txBody>
-      </p:sp>
-      <p:sp>
-        <p:nvSpPr>
-          <p:cNvPr id="47" name="TextBox 46"/>
-          <p:cNvSpPr txBox="1"/>
-          <p:nvPr/>
-        </p:nvSpPr>
-        <p:spPr>
-          <a:xfrm>
-            <a:off x="4407408" y="5586983"/>
-            <a:ext cx="7114032" cy="338328"/>
-          </a:xfrm>
-          <a:prstGeom prst="rect">
-            <a:avLst/>
-          </a:prstGeom>
-          <a:noFill/>
-        </p:spPr>
-        <p:txBody>
-          <a:bodyPr wrap="square" lIns="9144" rIns="9144" tIns="0" bIns="0">
-            <a:spAutoFit/>
-          </a:bodyPr>
-          <a:lstStyle/>
-          <a:p>
-            <a:pPr>
-              <a:spcAft>
-                <a:spcPts val="400"/>
-              </a:spcAft>
-              <a:defRPr sz="1200" b="0">
-                <a:solidFill>
-                  <a:srgbClr val="526874"/>
-                </a:solidFill>
-                <a:latin typeface="Noto Sans CJK TC"/>
-              </a:defRPr>
-            </a:pPr>
-            <a:r>
-              <a:t>同分排名、候選不足；股數參考價、最接近金額同距離及何時重算。</a:t>
-            </a:r>
-          </a:p>
-        </p:txBody>
-      </p:sp>
-      <p:sp>
-        <p:nvSpPr>
-          <p:cNvPr id="48" name="TextBox 47"/>
-          <p:cNvSpPr txBox="1"/>
-          <p:nvPr/>
-        </p:nvSpPr>
-        <p:spPr>
-          <a:xfrm>
-            <a:off x="502920" y="6153912"/>
-            <a:ext cx="10972800" cy="210312"/>
-          </a:xfrm>
-          <a:prstGeom prst="rect">
-            <a:avLst/>
-          </a:prstGeom>
-          <a:noFill/>
-        </p:spPr>
-        <p:txBody>
-          <a:bodyPr wrap="square" lIns="9144" rIns="9144" tIns="0" bIns="0">
-            <a:spAutoFit/>
-          </a:bodyPr>
-          <a:lstStyle/>
-          <a:p>
-            <a:pPr>
-              <a:spcAft>
-                <a:spcPts val="400"/>
-              </a:spcAft>
-              <a:defRPr sz="1100" b="1">
+              <a:defRPr sz="1000" b="1">
                 <a:solidFill>
                   <a:srgbClr val="AE671B"/>
                 </a:solidFill>
@@ -10262,7 +10469,7 @@
               </a:defRPr>
             </a:pPr>
             <a:r>
-              <a:t>每項均須形成可執行答案及對應測試；未決項目不可由開發者靜默補上。</a:t>
+              <a:t>已核對兩份逐字稿及五張原圖；01c 連結讀取遭 403 阻擋，內容尚未納入，不能視作沒有答案。</a:t>
             </a:r>
           </a:p>
         </p:txBody>
@@ -10366,7 +10573,7 @@
               </a:defRPr>
             </a:pPr>
             <a:r>
-              <a:t>開工前清單（二）：執行、介面及驗收</a:t>
+              <a:t>尚待落實清單（二）：執行、介面及驗收</a:t>
             </a:r>
           </a:p>
         </p:txBody>
@@ -10405,7 +10612,7 @@
               </a:defRPr>
             </a:pPr>
             <a:r>
-              <a:t>未拍板的相關功能須封鎖；可先建共用骨架，不能以預設假設冒充正式策略。</a:t>
+              <a:t>只確認未決執行細節及交付安排；先平倉再反手、時段尾清倉等策略原則沿用現有規格。</a:t>
             </a:r>
           </a:p>
         </p:txBody>
@@ -10488,7 +10695,7 @@
               </a:defRPr>
             </a:pPr>
             <a:r>
-              <a:t>依據：v3 規格、G3 修訂計劃及三份代理審閱｜審閱稿・2026 年 10 月 29 日｜引擎尚未建成</a:t>
+              <a:t>依據：v3、G3 計劃及原始來源核對｜修訂版・2026 年 10 月 29 日｜引擎尚未建成</a:t>
             </a:r>
           </a:p>
         </p:txBody>
@@ -12448,7 +12655,7 @@
               </a:defRPr>
             </a:pPr>
             <a:r>
-              <a:t>依據：v3 規格、G3 修訂計劃及三份代理審閱｜審閱稿・2026 年 10 月 29 日｜引擎尚未建成</a:t>
+              <a:t>依據：v3、G3 計劃及原始來源核對｜修訂版・2026 年 10 月 29 日｜引擎尚未建成</a:t>
             </a:r>
           </a:p>
         </p:txBody>
@@ -13565,7 +13772,7 @@
               </a:defRPr>
             </a:pPr>
             <a:r>
-              <a:t>依據：v3 規格、G3 修訂計劃及三份代理審閱｜審閱稿・2026 年 10 月 29 日｜引擎尚未建成</a:t>
+              <a:t>依據：v3、G3 計劃及原始來源核對｜修訂版・2026 年 10 月 29 日｜引擎尚未建成</a:t>
             </a:r>
           </a:p>
         </p:txBody>
@@ -13730,7 +13937,7 @@
               </a:defRPr>
             </a:pPr>
             <a:r>
-              <a:t>首版理想化成交須披露借貨、購買力及流動性限制。</a:t>
+              <a:t>若首版採理想化成交，須披露借貨、購買力及流動性限制。</a:t>
             </a:r>
           </a:p>
           <a:p>

</xml_diff>